<commit_message>
Add one-pager leave-behinds and update decks
Add PDF and PPTX one-pager leave-behinds for all 8 agents, update deck sources and documentation.

Co-Authored-By: Claude Opus 4.6 (1M context) <noreply@anthropic.com>
</commit_message>
<xml_diff>
--- a/decks/SLG-06-Procurement-Grants.pptx
+++ b/decks/SLG-06-Procurement-Grants.pptx
@@ -507,7 +507,7 @@
           <a:p>
             <a:r>
               <a:rPr lang="en-US" dirty="0"/>
-              <a:t>[~30 sec] Be the most honest on this one — it's the agent with the weakest outcome evidence, and saying so out loud builds credibility for the rest. Frame it as drafting assistance with award authority untouched.</a:t>
+              <a:t>[~30 sec] Frame this as drafting assistance with award authority untouched — but you now have a strong NAMED proof point (Oklahoma) that AI is already delivering hard procurement value at the state level, so you no longer have to be apologetic. Lead with the named state, then bring it back to the drafting agent.</a:t>
             </a:r>
             <a:endParaRPr lang="en-US" dirty="0"/>
           </a:p>
@@ -947,7 +947,7 @@
           <a:p>
             <a:r>
               <a:rPr lang="en-US" dirty="0"/>
-              <a:t>[~60 sec] Say it straight: I could not verify a named government deployment with a hard procurement-AI metric, so I'm not dressing one up. The ~70% drafting-time reduction is a real vendor claim but from an unnamed state DOT — labeled on the slide as vendor/unnamed. The honest, defensible pitch is: the writing burden is where AI safely helps; everything consequential stays human and audited. That candor is itself a selling point to a skeptical CISO.</a:t>
+              <a:t>[~75 sec] You now have a genuinely strong NAMED proof point — use it. Oklahoma's OMES (Celonis Process Copilot on the state's PeopleSoft data) flagged $6.8B in purchasing inefficiencies and, after a legislative report found $3B of purchases lacked oversight, reviewed ALL procurement for 100+ agencies in 60 days — versus up to 8 audits a year before, often on purchases 2-3 years old (GovTech, named official Janet Morrow, Feb 2025). One honesty caveat to keep in your pocket: Oklahoma is procurement OVERSIGHT / spend-analytics AI, not solicitation drafting — so present it as proof that AI returns hard dollars in state procurement, then bring it back to what THIS agent does (governed drafting). Pennsylvania's ChatGPT Enterprise pilot adds a second named state (~8 hrs/week per worker, Gov. Shapiro on the record, with procurement a named beneficiary). Dallas + Hazel AI is a named city doing solicitation drafting with AI but no hard metric yet — use as 'adoption is real, drafting outcomes still emerging.' And be straight that no named state/local GRANTS-AI deployment with a hard metric exists yet — keep grants framed as drafting/intake assistance.</a:t>
             </a:r>
             <a:endParaRPr lang="en-US" dirty="0"/>
           </a:p>
@@ -6648,7 +6648,7 @@
                 <a:ea typeface="Trebuchet MS" pitchFamily="34" charset="-122"/>
                 <a:cs typeface="Trebuchet MS" pitchFamily="34" charset="-120"/>
               </a:rPr>
-              <a:t>Less time writing, more time competing and awarding well.</a:t>
+              <a:t>States are already getting hard, named value from procurement AI.</a:t>
             </a:r>
             <a:endParaRPr lang="en-US" sz="2500" dirty="0"/>
           </a:p>
@@ -6706,7 +6706,7 @@
               <a:buNone/>
             </a:pPr>
             <a:r>
-              <a:rPr lang="en-US" sz="2800" b="1" dirty="0">
+              <a:rPr lang="en-US" sz="3400" b="1" dirty="0">
                 <a:solidFill>
                   <a:srgbClr val="FF9900"/>
                 </a:solidFill>
@@ -6714,9 +6714,9 @@
                 <a:ea typeface="Trebuchet MS" pitchFamily="34" charset="-122"/>
                 <a:cs typeface="Trebuchet MS" pitchFamily="34" charset="-120"/>
               </a:rPr>
-              <a:t>~70% less</a:t>
-            </a:r>
-            <a:endParaRPr lang="en-US" sz="2800" dirty="0"/>
+              <a:t>$6.8B</a:t>
+            </a:r>
+            <a:endParaRPr lang="en-US" sz="3400" dirty="0"/>
           </a:p>
         </p:txBody>
       </p:sp>
@@ -6756,7 +6756,7 @@
                 <a:ea typeface="Calibri" pitchFamily="34" charset="-122"/>
                 <a:cs typeface="Calibri" pitchFamily="34" charset="-120"/>
               </a:rPr>
-              <a:t>RFP-drafting time using an AI assistant trained on prior solicitations</a:t>
+              <a:t>purchasing inefficiencies flagged by Oklahoma OMES procurement AI</a:t>
             </a:r>
             <a:endParaRPr lang="en-US" sz="1100" dirty="0"/>
           </a:p>
@@ -6771,7 +6771,7 @@
         <p:spPr>
           <a:xfrm>
             <a:off x="1024128" y="3118104"/>
-            <a:ext cx="1962302" cy="256032"/>
+            <a:ext cx="1062533" cy="256032"/>
           </a:xfrm>
           <a:prstGeom prst="rect">
             <a:avLst>
@@ -6799,7 +6799,7 @@
                 <a:ea typeface="Calibri" pitchFamily="34" charset="-122"/>
                 <a:cs typeface="Calibri" pitchFamily="34" charset="-120"/>
               </a:rPr>
-              <a:t>VENDOR · UNNAMED AGENCY</a:t>
+              <a:t>NAMED STATE</a:t>
             </a:r>
             <a:endParaRPr lang="en-US" sz="800" dirty="0"/>
           </a:p>
@@ -6857,7 +6857,7 @@
               <a:buNone/>
             </a:pPr>
             <a:r>
-              <a:rPr lang="en-US" sz="2800" b="1" dirty="0">
+              <a:rPr lang="en-US" sz="2200" b="1" dirty="0">
                 <a:solidFill>
                   <a:srgbClr val="FF9900"/>
                 </a:solidFill>
@@ -6865,9 +6865,9 @@
                 <a:ea typeface="Trebuchet MS" pitchFamily="34" charset="-122"/>
                 <a:cs typeface="Trebuchet MS" pitchFamily="34" charset="-120"/>
               </a:rPr>
-              <a:t>57 → faster</a:t>
-            </a:r>
-            <a:endParaRPr lang="en-US" sz="2800" dirty="0"/>
+              <a:t>All spend, 60 days</a:t>
+            </a:r>
+            <a:endParaRPr lang="en-US" sz="2200" dirty="0"/>
           </a:p>
         </p:txBody>
       </p:sp>
@@ -6907,7 +6907,7 @@
                 <a:ea typeface="Calibri" pitchFamily="34" charset="-122"/>
                 <a:cs typeface="Calibri" pitchFamily="34" charset="-120"/>
               </a:rPr>
-              <a:t>compress the writing share of the posting-to-award cycle</a:t>
+              <a:t>Oklahoma reviewed all state procurement vs. ~8 audits/year before</a:t>
             </a:r>
             <a:endParaRPr lang="en-US" sz="1100" dirty="0"/>
           </a:p>
@@ -6950,7 +6950,7 @@
                 <a:ea typeface="Calibri" pitchFamily="34" charset="-122"/>
                 <a:cs typeface="Calibri" pitchFamily="34" charset="-120"/>
               </a:rPr>
-              <a:t>DIRECTIONAL</a:t>
+              <a:t>NAMED STATE</a:t>
             </a:r>
             <a:endParaRPr lang="en-US" sz="800" dirty="0"/>
           </a:p>
@@ -7008,7 +7008,7 @@
               <a:buNone/>
             </a:pPr>
             <a:r>
-              <a:rPr lang="en-US" sz="2400" b="1" dirty="0">
+              <a:rPr lang="en-US" sz="2600" b="1" dirty="0">
                 <a:solidFill>
                   <a:srgbClr val="FF9900"/>
                 </a:solidFill>
@@ -7016,9 +7016,9 @@
                 <a:ea typeface="Trebuchet MS" pitchFamily="34" charset="-122"/>
                 <a:cs typeface="Trebuchet MS" pitchFamily="34" charset="-120"/>
               </a:rPr>
-              <a:t>Audit-by-design</a:t>
-            </a:r>
-            <a:endParaRPr lang="en-US" sz="2400" dirty="0"/>
+              <a:t>8 hrs / week</a:t>
+            </a:r>
+            <a:endParaRPr lang="en-US" sz="2600" dirty="0"/>
           </a:p>
         </p:txBody>
       </p:sp>
@@ -7058,7 +7058,7 @@
                 <a:ea typeface="Calibri" pitchFamily="34" charset="-122"/>
                 <a:cs typeface="Calibri" pitchFamily="34" charset="-120"/>
               </a:rPr>
-              <a:t>every draft, edit and award rationale captured immutably</a:t>
+              <a:t>saved per worker in Pennsylvania's AI pilot (procurement a named use case)</a:t>
             </a:r>
             <a:endParaRPr lang="en-US" sz="1100" dirty="0"/>
           </a:p>
@@ -7073,7 +7073,7 @@
         <p:spPr>
           <a:xfrm>
             <a:off x="8217408" y="3118104"/>
-            <a:ext cx="1137514" cy="256032"/>
+            <a:ext cx="1062533" cy="256032"/>
           </a:xfrm>
           <a:prstGeom prst="rect">
             <a:avLst>
@@ -7101,7 +7101,7 @@
                 <a:ea typeface="Calibri" pitchFamily="34" charset="-122"/>
                 <a:cs typeface="Calibri" pitchFamily="34" charset="-120"/>
               </a:rPr>
-              <a:t>ARCHITECTURE</a:t>
+              <a:t>NAMED STATE</a:t>
             </a:r>
             <a:endParaRPr lang="en-US" sz="800" dirty="0"/>
           </a:p>
@@ -7182,7 +7182,7 @@
                 <a:ea typeface="Calibri" pitchFamily="34" charset="-122"/>
                 <a:cs typeface="Calibri" pitchFamily="34" charset="-120"/>
               </a:rPr>
-              <a:t>The writing burden — dozens of hours per solicitation — is where AI safely helps. Faster, more complete drafts mean more solicitations out the door and stronger competition, while evaluation and award stay human and every version is logged for protest defense.</a:t>
+              <a:t>Named states are turning AI on procurement into hard dollars: Oklahoma flagged $6.8B in inefficiencies and reviewed all state spend in 60 days. This agent applies the same governed pattern to the writing burden — faster, more complete solicitations and more competition — while evaluation and award stay human and every version is logged for protest defense.</a:t>
             </a:r>
             <a:endParaRPr lang="en-US" sz="1150" dirty="0"/>
           </a:p>

</xml_diff>